<commit_message>
Drop numbered labels from the APN guideline PowerPoint.
Titles, cards, steps, and the footer no longer show 01 / 1 of 12 / section numbers.

Co-authored-by: Cursor <cursoragent@cursor.com>
</commit_message>
<xml_diff>
--- a/GAP-GUIDE-2026-001-APN-Opportunity-Lark-Base.pptx
+++ b/GAP-GUIDE-2026-001-APN-Opportunity-Lark-Base.pptx
@@ -3261,7 +3261,7 @@
                 </a:solidFill>
                 <a:latin typeface="Calibri"/>
               </a:rPr>
-              <a:t>GAP-GUIDE-2026-001  ·  V1.1  ·  ISSUED</a:t>
+              <a:t>OFFICIAL DOCUMENTATION  ·  V1.1  ·  ISSUED</a:t>
             </a:r>
           </a:p>
         </p:txBody>
@@ -3375,7 +3375,7 @@
         <p:spPr>
           <a:xfrm>
             <a:off x="457200" y="6565392"/>
-            <a:ext cx="8686800" cy="219456"/>
+            <a:ext cx="11247120" cy="219456"/>
           </a:xfrm>
           <a:prstGeom prst="rect">
             <a:avLst/>
@@ -3394,40 +3394,7 @@
                 </a:solidFill>
                 <a:latin typeface="Calibri"/>
               </a:rPr>
-              <a:t>GAP-GUIDE-2026-001  ·  Internal  ·  v1.1</a:t>
-            </a:r>
-          </a:p>
-        </p:txBody>
-      </p:sp>
-      <p:sp>
-        <p:nvSpPr>
-          <p:cNvPr id="11" name="TextBox 10"/>
-          <p:cNvSpPr txBox="1"/>
-          <p:nvPr/>
-        </p:nvSpPr>
-        <p:spPr>
-          <a:xfrm>
-            <a:off x="9509760" y="6565392"/>
-            <a:ext cx="2194560" cy="219456"/>
-          </a:xfrm>
-          <a:prstGeom prst="rect">
-            <a:avLst/>
-          </a:prstGeom>
-          <a:noFill/>
-        </p:spPr>
-        <p:txBody>
-          <a:bodyPr wrap="square" a:anchor="t"/>
-          <a:lstStyle/>
-          <a:p>
-            <a:pPr algn="r"/>
-            <a:r>
-              <a:rPr sz="1000" b="0">
-                <a:solidFill>
-                  <a:srgbClr val="C8C0B4"/>
-                </a:solidFill>
-                <a:latin typeface="Calibri"/>
-              </a:rPr>
-              <a:t>1 / 12</a:t>
+              <a:t>Internal  ·  v1.1  ·  © G-AsiaPacific</a:t>
             </a:r>
           </a:p>
         </p:txBody>
@@ -3521,7 +3488,7 @@
                 </a:solidFill>
                 <a:latin typeface="Calibri"/>
               </a:rPr>
-              <a:t>9. FORMAT — WHY ROWS FAIL</a:t>
+              <a:t>FORMAT — WHY ROWS FAIL</a:t>
             </a:r>
           </a:p>
         </p:txBody>
@@ -3612,27 +3579,27 @@
         </p:nvSpPr>
         <p:spPr>
           <a:xfrm>
-            <a:off x="640080" y="1508760"/>
-            <a:ext cx="3200400" cy="365760"/>
-          </a:xfrm>
-          <a:prstGeom prst="rect">
-            <a:avLst/>
-          </a:prstGeom>
-          <a:noFill/>
-        </p:spPr>
-        <p:txBody>
-          <a:bodyPr wrap="square" a:anchor="t"/>
-          <a:lstStyle/>
-          <a:p>
-            <a:pPr algn="l"/>
-            <a:r>
-              <a:rPr sz="1400" b="1">
-                <a:solidFill>
-                  <a:srgbClr val="E87722"/>
-                </a:solidFill>
-                <a:latin typeface="Calibri"/>
-              </a:rPr>
-              <a:t>01</a:t>
+            <a:off x="640080" y="1600200"/>
+            <a:ext cx="3246120" cy="1097280"/>
+          </a:xfrm>
+          <a:prstGeom prst="rect">
+            <a:avLst/>
+          </a:prstGeom>
+          <a:noFill/>
+        </p:spPr>
+        <p:txBody>
+          <a:bodyPr wrap="square" a:anchor="t"/>
+          <a:lstStyle/>
+          <a:p>
+            <a:pPr algn="l"/>
+            <a:r>
+              <a:rPr sz="2200" b="1">
+                <a:solidFill>
+                  <a:srgbClr val="1B2A4A"/>
+                </a:solidFill>
+                <a:latin typeface="Calibri"/>
+              </a:rPr>
+              <a:t>Problem ≥ 20 characters</a:t>
             </a:r>
           </a:p>
         </p:txBody>
@@ -3645,41 +3612,8 @@
         </p:nvSpPr>
         <p:spPr>
           <a:xfrm>
-            <a:off x="640080" y="2011680"/>
-            <a:ext cx="3246120" cy="1005840"/>
-          </a:xfrm>
-          <a:prstGeom prst="rect">
-            <a:avLst/>
-          </a:prstGeom>
-          <a:noFill/>
-        </p:spPr>
-        <p:txBody>
-          <a:bodyPr wrap="square" a:anchor="t"/>
-          <a:lstStyle/>
-          <a:p>
-            <a:pPr algn="l"/>
-            <a:r>
-              <a:rPr sz="2200" b="1">
-                <a:solidFill>
-                  <a:srgbClr val="1B2A4A"/>
-                </a:solidFill>
-                <a:latin typeface="Calibri"/>
-              </a:rPr>
-              <a:t>Problem ≥ 20 characters</a:t>
-            </a:r>
-          </a:p>
-        </p:txBody>
-      </p:sp>
-      <p:sp>
-        <p:nvSpPr>
-          <p:cNvPr id="8" name="TextBox 7"/>
-          <p:cNvSpPr txBox="1"/>
-          <p:nvPr/>
-        </p:nvSpPr>
-        <p:spPr>
-          <a:xfrm>
-            <a:off x="640080" y="3200400"/>
-            <a:ext cx="3246120" cy="1645920"/>
+            <a:off x="640080" y="2926080"/>
+            <a:ext cx="3246120" cy="1828800"/>
           </a:xfrm>
           <a:prstGeom prst="rect">
             <a:avLst/>
@@ -3705,7 +3639,7 @@
       </p:sp>
       <p:sp>
         <p:nvSpPr>
-          <p:cNvPr id="9" name="Rounded Rectangle 8"/>
+          <p:cNvPr id="8" name="Rounded Rectangle 7"/>
           <p:cNvSpPr/>
           <p:nvPr/>
         </p:nvSpPr>
@@ -3750,80 +3684,47 @@
       </p:sp>
       <p:sp>
         <p:nvSpPr>
+          <p:cNvPr id="9" name="TextBox 8"/>
+          <p:cNvSpPr txBox="1"/>
+          <p:nvPr/>
+        </p:nvSpPr>
+        <p:spPr>
+          <a:xfrm>
+            <a:off x="4526280" y="1600200"/>
+            <a:ext cx="3246120" cy="1097280"/>
+          </a:xfrm>
+          <a:prstGeom prst="rect">
+            <a:avLst/>
+          </a:prstGeom>
+          <a:noFill/>
+        </p:spPr>
+        <p:txBody>
+          <a:bodyPr wrap="square" a:anchor="t"/>
+          <a:lstStyle/>
+          <a:p>
+            <a:pPr algn="l"/>
+            <a:r>
+              <a:rPr sz="2200" b="1">
+                <a:solidFill>
+                  <a:srgbClr val="1B2A4A"/>
+                </a:solidFill>
+                <a:latin typeface="Calibri"/>
+              </a:rPr>
+              <a:t>Phone E.164</a:t>
+            </a:r>
+          </a:p>
+        </p:txBody>
+      </p:sp>
+      <p:sp>
+        <p:nvSpPr>
           <p:cNvPr id="10" name="TextBox 9"/>
           <p:cNvSpPr txBox="1"/>
           <p:nvPr/>
         </p:nvSpPr>
         <p:spPr>
           <a:xfrm>
-            <a:off x="4526280" y="1508760"/>
-            <a:ext cx="3200400" cy="365760"/>
-          </a:xfrm>
-          <a:prstGeom prst="rect">
-            <a:avLst/>
-          </a:prstGeom>
-          <a:noFill/>
-        </p:spPr>
-        <p:txBody>
-          <a:bodyPr wrap="square" a:anchor="t"/>
-          <a:lstStyle/>
-          <a:p>
-            <a:pPr algn="l"/>
-            <a:r>
-              <a:rPr sz="1400" b="1">
-                <a:solidFill>
-                  <a:srgbClr val="E87722"/>
-                </a:solidFill>
-                <a:latin typeface="Calibri"/>
-              </a:rPr>
-              <a:t>02</a:t>
-            </a:r>
-          </a:p>
-        </p:txBody>
-      </p:sp>
-      <p:sp>
-        <p:nvSpPr>
-          <p:cNvPr id="11" name="TextBox 10"/>
-          <p:cNvSpPr txBox="1"/>
-          <p:nvPr/>
-        </p:nvSpPr>
-        <p:spPr>
-          <a:xfrm>
-            <a:off x="4526280" y="2011680"/>
-            <a:ext cx="3246120" cy="1005840"/>
-          </a:xfrm>
-          <a:prstGeom prst="rect">
-            <a:avLst/>
-          </a:prstGeom>
-          <a:noFill/>
-        </p:spPr>
-        <p:txBody>
-          <a:bodyPr wrap="square" a:anchor="t"/>
-          <a:lstStyle/>
-          <a:p>
-            <a:pPr algn="l"/>
-            <a:r>
-              <a:rPr sz="2200" b="1">
-                <a:solidFill>
-                  <a:srgbClr val="1B2A4A"/>
-                </a:solidFill>
-                <a:latin typeface="Calibri"/>
-              </a:rPr>
-              <a:t>Phone E.164</a:t>
-            </a:r>
-          </a:p>
-        </p:txBody>
-      </p:sp>
-      <p:sp>
-        <p:nvSpPr>
-          <p:cNvPr id="12" name="TextBox 11"/>
-          <p:cNvSpPr txBox="1"/>
-          <p:nvPr/>
-        </p:nvSpPr>
-        <p:spPr>
-          <a:xfrm>
-            <a:off x="4526280" y="3200400"/>
-            <a:ext cx="3246120" cy="1645920"/>
+            <a:off x="4526280" y="2926080"/>
+            <a:ext cx="3246120" cy="1828800"/>
           </a:xfrm>
           <a:prstGeom prst="rect">
             <a:avLst/>
@@ -3849,7 +3750,7 @@
       </p:sp>
       <p:sp>
         <p:nvSpPr>
-          <p:cNvPr id="13" name="Rounded Rectangle 12"/>
+          <p:cNvPr id="11" name="Rounded Rectangle 10"/>
           <p:cNvSpPr/>
           <p:nvPr/>
         </p:nvSpPr>
@@ -3894,113 +3795,80 @@
       </p:sp>
       <p:sp>
         <p:nvSpPr>
+          <p:cNvPr id="12" name="TextBox 11"/>
+          <p:cNvSpPr txBox="1"/>
+          <p:nvPr/>
+        </p:nvSpPr>
+        <p:spPr>
+          <a:xfrm>
+            <a:off x="8412479" y="1600200"/>
+            <a:ext cx="3246120" cy="1097280"/>
+          </a:xfrm>
+          <a:prstGeom prst="rect">
+            <a:avLst/>
+          </a:prstGeom>
+          <a:noFill/>
+        </p:spPr>
+        <p:txBody>
+          <a:bodyPr wrap="square" a:anchor="t"/>
+          <a:lstStyle/>
+          <a:p>
+            <a:pPr algn="l"/>
+            <a:r>
+              <a:rPr sz="2200" b="1">
+                <a:solidFill>
+                  <a:srgbClr val="1B2A4A"/>
+                </a:solidFill>
+                <a:latin typeface="Calibri"/>
+              </a:rPr>
+              <a:t>Launched Stage</a:t>
+            </a:r>
+          </a:p>
+        </p:txBody>
+      </p:sp>
+      <p:sp>
+        <p:nvSpPr>
+          <p:cNvPr id="13" name="TextBox 12"/>
+          <p:cNvSpPr txBox="1"/>
+          <p:nvPr/>
+        </p:nvSpPr>
+        <p:spPr>
+          <a:xfrm>
+            <a:off x="8412479" y="2926080"/>
+            <a:ext cx="3246120" cy="1828800"/>
+          </a:xfrm>
+          <a:prstGeom prst="rect">
+            <a:avLst/>
+          </a:prstGeom>
+          <a:noFill/>
+        </p:spPr>
+        <p:txBody>
+          <a:bodyPr wrap="square" a:anchor="t"/>
+          <a:lstStyle/>
+          <a:p>
+            <a:pPr algn="l"/>
+            <a:r>
+              <a:rPr sz="1500" b="0">
+                <a:solidFill>
+                  <a:srgbClr val="5A564E"/>
+                </a:solidFill>
+                <a:latin typeface="Calibri"/>
+              </a:rPr>
+              <a:t>You must have AWS Account ID. Missing ID = Failed.</a:t>
+            </a:r>
+          </a:p>
+        </p:txBody>
+      </p:sp>
+      <p:sp>
+        <p:nvSpPr>
           <p:cNvPr id="14" name="TextBox 13"/>
           <p:cNvSpPr txBox="1"/>
           <p:nvPr/>
         </p:nvSpPr>
         <p:spPr>
           <a:xfrm>
-            <a:off x="8412479" y="1508760"/>
-            <a:ext cx="3200400" cy="365760"/>
-          </a:xfrm>
-          <a:prstGeom prst="rect">
-            <a:avLst/>
-          </a:prstGeom>
-          <a:noFill/>
-        </p:spPr>
-        <p:txBody>
-          <a:bodyPr wrap="square" a:anchor="t"/>
-          <a:lstStyle/>
-          <a:p>
-            <a:pPr algn="l"/>
-            <a:r>
-              <a:rPr sz="1400" b="1">
-                <a:solidFill>
-                  <a:srgbClr val="E87722"/>
-                </a:solidFill>
-                <a:latin typeface="Calibri"/>
-              </a:rPr>
-              <a:t>03</a:t>
-            </a:r>
-          </a:p>
-        </p:txBody>
-      </p:sp>
-      <p:sp>
-        <p:nvSpPr>
-          <p:cNvPr id="15" name="TextBox 14"/>
-          <p:cNvSpPr txBox="1"/>
-          <p:nvPr/>
-        </p:nvSpPr>
-        <p:spPr>
-          <a:xfrm>
-            <a:off x="8412479" y="2011680"/>
-            <a:ext cx="3246120" cy="1005840"/>
-          </a:xfrm>
-          <a:prstGeom prst="rect">
-            <a:avLst/>
-          </a:prstGeom>
-          <a:noFill/>
-        </p:spPr>
-        <p:txBody>
-          <a:bodyPr wrap="square" a:anchor="t"/>
-          <a:lstStyle/>
-          <a:p>
-            <a:pPr algn="l"/>
-            <a:r>
-              <a:rPr sz="2200" b="1">
-                <a:solidFill>
-                  <a:srgbClr val="1B2A4A"/>
-                </a:solidFill>
-                <a:latin typeface="Calibri"/>
-              </a:rPr>
-              <a:t>Launched Stage</a:t>
-            </a:r>
-          </a:p>
-        </p:txBody>
-      </p:sp>
-      <p:sp>
-        <p:nvSpPr>
-          <p:cNvPr id="16" name="TextBox 15"/>
-          <p:cNvSpPr txBox="1"/>
-          <p:nvPr/>
-        </p:nvSpPr>
-        <p:spPr>
-          <a:xfrm>
-            <a:off x="8412479" y="3200400"/>
-            <a:ext cx="3246120" cy="1645920"/>
-          </a:xfrm>
-          <a:prstGeom prst="rect">
-            <a:avLst/>
-          </a:prstGeom>
-          <a:noFill/>
-        </p:spPr>
-        <p:txBody>
-          <a:bodyPr wrap="square" a:anchor="t"/>
-          <a:lstStyle/>
-          <a:p>
-            <a:pPr algn="l"/>
-            <a:r>
-              <a:rPr sz="1500" b="0">
-                <a:solidFill>
-                  <a:srgbClr val="5A564E"/>
-                </a:solidFill>
-                <a:latin typeface="Calibri"/>
-              </a:rPr>
-              <a:t>You must have AWS Account ID. Missing ID = Failed.</a:t>
-            </a:r>
-          </a:p>
-        </p:txBody>
-      </p:sp>
-      <p:sp>
-        <p:nvSpPr>
-          <p:cNvPr id="17" name="TextBox 16"/>
-          <p:cNvSpPr txBox="1"/>
-          <p:nvPr/>
-        </p:nvSpPr>
-        <p:spPr>
-          <a:xfrm>
             <a:off x="457200" y="6565392"/>
-            <a:ext cx="8686800" cy="219456"/>
+            <a:ext cx="11247120" cy="219456"/>
           </a:xfrm>
           <a:prstGeom prst="rect">
             <a:avLst/>
@@ -4019,40 +3887,7 @@
                 </a:solidFill>
                 <a:latin typeface="Calibri"/>
               </a:rPr>
-              <a:t>GAP-GUIDE-2026-001  ·  Internal  ·  v1.1</a:t>
-            </a:r>
-          </a:p>
-        </p:txBody>
-      </p:sp>
-      <p:sp>
-        <p:nvSpPr>
-          <p:cNvPr id="18" name="TextBox 17"/>
-          <p:cNvSpPr txBox="1"/>
-          <p:nvPr/>
-        </p:nvSpPr>
-        <p:spPr>
-          <a:xfrm>
-            <a:off x="9509760" y="6565392"/>
-            <a:ext cx="2194560" cy="219456"/>
-          </a:xfrm>
-          <a:prstGeom prst="rect">
-            <a:avLst/>
-          </a:prstGeom>
-          <a:noFill/>
-        </p:spPr>
-        <p:txBody>
-          <a:bodyPr wrap="square" a:anchor="t"/>
-          <a:lstStyle/>
-          <a:p>
-            <a:pPr algn="r"/>
-            <a:r>
-              <a:rPr sz="1000" b="0">
-                <a:solidFill>
-                  <a:srgbClr val="8A8478"/>
-                </a:solidFill>
-                <a:latin typeface="Calibri"/>
-              </a:rPr>
-              <a:t>10 / 12</a:t>
+              <a:t>Internal  ·  v1.1  ·  © G-AsiaPacific</a:t>
             </a:r>
           </a:p>
         </p:txBody>
@@ -4213,7 +4048,7 @@
                 </a:solidFill>
                 <a:latin typeface="Calibri"/>
               </a:rPr>
-              <a:t>10–12  EXISTING AND GO-LIVE</a:t>
+              <a:t>EXISTING OPPORTUNITIES AND GO-LIVE</a:t>
             </a:r>
           </a:p>
         </p:txBody>
@@ -4331,7 +4166,7 @@
         <p:spPr>
           <a:xfrm>
             <a:off x="457200" y="6565392"/>
-            <a:ext cx="8686800" cy="219456"/>
+            <a:ext cx="11247120" cy="219456"/>
           </a:xfrm>
           <a:prstGeom prst="rect">
             <a:avLst/>
@@ -4350,40 +4185,7 @@
                 </a:solidFill>
                 <a:latin typeface="Calibri"/>
               </a:rPr>
-              <a:t>GAP-GUIDE-2026-001  ·  Internal  ·  v1.1</a:t>
-            </a:r>
-          </a:p>
-        </p:txBody>
-      </p:sp>
-      <p:sp>
-        <p:nvSpPr>
-          <p:cNvPr id="9" name="TextBox 8"/>
-          <p:cNvSpPr txBox="1"/>
-          <p:nvPr/>
-        </p:nvSpPr>
-        <p:spPr>
-          <a:xfrm>
-            <a:off x="9509760" y="6565392"/>
-            <a:ext cx="2194560" cy="219456"/>
-          </a:xfrm>
-          <a:prstGeom prst="rect">
-            <a:avLst/>
-          </a:prstGeom>
-          <a:noFill/>
-        </p:spPr>
-        <p:txBody>
-          <a:bodyPr wrap="square" a:anchor="t"/>
-          <a:lstStyle/>
-          <a:p>
-            <a:pPr algn="r"/>
-            <a:r>
-              <a:rPr sz="1000" b="0">
-                <a:solidFill>
-                  <a:srgbClr val="C8C0B4"/>
-                </a:solidFill>
-                <a:latin typeface="Calibri"/>
-              </a:rPr>
-              <a:t>11 / 12</a:t>
+              <a:t>Internal  ·  v1.1  ·  © G-AsiaPacific</a:t>
             </a:r>
           </a:p>
         </p:txBody>
@@ -4477,7 +4279,7 @@
                 </a:solidFill>
                 <a:latin typeface="Calibri"/>
               </a:rPr>
-              <a:t>11. IF YOU ARE STUCK</a:t>
+              <a:t>IF YOU ARE STUCK</a:t>
             </a:r>
           </a:p>
         </p:txBody>
@@ -4588,7 +4390,7 @@
                 </a:solidFill>
                 <a:latin typeface="Calibri"/>
               </a:rPr>
-              <a:t>01  ·  APN TroubleShoot</a:t>
+              <a:t>APN TroubleShoot</a:t>
             </a:r>
           </a:p>
         </p:txBody>
@@ -4660,7 +4462,7 @@
                 </a:solidFill>
                 <a:latin typeface="Calibri"/>
               </a:rPr>
-              <a:t>1. Your Oppt ID</a:t>
+              <a:t>Your Oppt ID</a:t>
             </a:r>
           </a:p>
           <a:p>
@@ -4676,7 +4478,7 @@
                 </a:solidFill>
                 <a:latin typeface="Calibri"/>
               </a:rPr>
-              <a:t>2. Your Status (Sync_Status / AWS_Review_Status)</a:t>
+              <a:t>Your Status (Sync_Status / AWS_Review_Status)</a:t>
             </a:r>
           </a:p>
           <a:p>
@@ -4692,7 +4494,7 @@
                 </a:solidFill>
                 <a:latin typeface="Calibri"/>
               </a:rPr>
-              <a:t>3. Your Sync_Message</a:t>
+              <a:t>Your Sync_Message</a:t>
             </a:r>
           </a:p>
         </p:txBody>
@@ -4770,7 +4572,7 @@
                 </a:solidFill>
                 <a:latin typeface="Calibri"/>
               </a:rPr>
-              <a:t>02  ·  APN flow</a:t>
+              <a:t>APN flow</a:t>
             </a:r>
           </a:p>
         </p:txBody>
@@ -4907,7 +4709,7 @@
         <p:spPr>
           <a:xfrm>
             <a:off x="457200" y="6565392"/>
-            <a:ext cx="8686800" cy="219456"/>
+            <a:ext cx="11247120" cy="219456"/>
           </a:xfrm>
           <a:prstGeom prst="rect">
             <a:avLst/>
@@ -4926,40 +4728,7 @@
                 </a:solidFill>
                 <a:latin typeface="Calibri"/>
               </a:rPr>
-              <a:t>GAP-GUIDE-2026-001  ·  Internal  ·  v1.1</a:t>
-            </a:r>
-          </a:p>
-        </p:txBody>
-      </p:sp>
-      <p:sp>
-        <p:nvSpPr>
-          <p:cNvPr id="16" name="TextBox 15"/>
-          <p:cNvSpPr txBox="1"/>
-          <p:nvPr/>
-        </p:nvSpPr>
-        <p:spPr>
-          <a:xfrm>
-            <a:off x="9509760" y="6565392"/>
-            <a:ext cx="2194560" cy="219456"/>
-          </a:xfrm>
-          <a:prstGeom prst="rect">
-            <a:avLst/>
-          </a:prstGeom>
-          <a:noFill/>
-        </p:spPr>
-        <p:txBody>
-          <a:bodyPr wrap="square" a:anchor="t"/>
-          <a:lstStyle/>
-          <a:p>
-            <a:pPr algn="r"/>
-            <a:r>
-              <a:rPr sz="1000" b="0">
-                <a:solidFill>
-                  <a:srgbClr val="8A8478"/>
-                </a:solidFill>
-                <a:latin typeface="Calibri"/>
-              </a:rPr>
-              <a:t>12 / 12</a:t>
+              <a:t>Internal  ·  v1.1  ·  © G-AsiaPacific</a:t>
             </a:r>
           </a:p>
         </p:txBody>
@@ -5077,7 +4846,7 @@
                 </a:solidFill>
                 <a:latin typeface="Calibri"/>
               </a:rPr>
-              <a:t>2. WHY LARK</a:t>
+              <a:t>WHY LARK</a:t>
             </a:r>
           </a:p>
         </p:txBody>
@@ -5195,7 +4964,7 @@
         <p:spPr>
           <a:xfrm>
             <a:off x="457200" y="6565392"/>
-            <a:ext cx="8686800" cy="219456"/>
+            <a:ext cx="11247120" cy="219456"/>
           </a:xfrm>
           <a:prstGeom prst="rect">
             <a:avLst/>
@@ -5214,40 +4983,7 @@
                 </a:solidFill>
                 <a:latin typeface="Calibri"/>
               </a:rPr>
-              <a:t>GAP-GUIDE-2026-001  ·  Internal  ·  v1.1</a:t>
-            </a:r>
-          </a:p>
-        </p:txBody>
-      </p:sp>
-      <p:sp>
-        <p:nvSpPr>
-          <p:cNvPr id="8" name="TextBox 7"/>
-          <p:cNvSpPr txBox="1"/>
-          <p:nvPr/>
-        </p:nvSpPr>
-        <p:spPr>
-          <a:xfrm>
-            <a:off x="9509760" y="6565392"/>
-            <a:ext cx="2194560" cy="219456"/>
-          </a:xfrm>
-          <a:prstGeom prst="rect">
-            <a:avLst/>
-          </a:prstGeom>
-          <a:noFill/>
-        </p:spPr>
-        <p:txBody>
-          <a:bodyPr wrap="square" a:anchor="t"/>
-          <a:lstStyle/>
-          <a:p>
-            <a:pPr algn="r"/>
-            <a:r>
-              <a:rPr sz="1000" b="0">
-                <a:solidFill>
-                  <a:srgbClr val="8A8478"/>
-                </a:solidFill>
-                <a:latin typeface="Calibri"/>
-              </a:rPr>
-              <a:t>2 / 12</a:t>
+              <a:t>Internal  ·  v1.1  ·  © G-AsiaPacific</a:t>
             </a:r>
           </a:p>
         </p:txBody>
@@ -5341,7 +5077,7 @@
                 </a:solidFill>
                 <a:latin typeface="Calibri"/>
               </a:rPr>
-              <a:t>3. WHAT YOU WILL SEE</a:t>
+              <a:t>WHAT YOU WILL SEE</a:t>
             </a:r>
           </a:p>
         </p:txBody>
@@ -5432,27 +5168,27 @@
         </p:nvSpPr>
         <p:spPr>
           <a:xfrm>
-            <a:off x="685800" y="1435608"/>
-            <a:ext cx="5166360" cy="320040"/>
-          </a:xfrm>
-          <a:prstGeom prst="rect">
-            <a:avLst/>
-          </a:prstGeom>
-          <a:noFill/>
-        </p:spPr>
-        <p:txBody>
-          <a:bodyPr wrap="square" a:anchor="t"/>
-          <a:lstStyle/>
-          <a:p>
-            <a:pPr algn="l"/>
-            <a:r>
-              <a:rPr sz="1200" b="1">
-                <a:solidFill>
-                  <a:srgbClr val="E87722"/>
-                </a:solidFill>
-                <a:latin typeface="Calibri"/>
-              </a:rPr>
-              <a:t>01</a:t>
+            <a:off x="685800" y="1554480"/>
+            <a:ext cx="5166360" cy="502920"/>
+          </a:xfrm>
+          <a:prstGeom prst="rect">
+            <a:avLst/>
+          </a:prstGeom>
+          <a:noFill/>
+        </p:spPr>
+        <p:txBody>
+          <a:bodyPr wrap="square" a:anchor="t"/>
+          <a:lstStyle/>
+          <a:p>
+            <a:pPr algn="l"/>
+            <a:r>
+              <a:rPr sz="1600" b="1">
+                <a:solidFill>
+                  <a:srgbClr val="1B2A4A"/>
+                </a:solidFill>
+                <a:latin typeface="Calibri"/>
+              </a:rPr>
+              <a:t>APN Oppt Submission Table</a:t>
             </a:r>
           </a:p>
         </p:txBody>
@@ -5465,41 +5201,8 @@
         </p:nvSpPr>
         <p:spPr>
           <a:xfrm>
-            <a:off x="685800" y="1737360"/>
-            <a:ext cx="5166360" cy="502920"/>
-          </a:xfrm>
-          <a:prstGeom prst="rect">
-            <a:avLst/>
-          </a:prstGeom>
-          <a:noFill/>
-        </p:spPr>
-        <p:txBody>
-          <a:bodyPr wrap="square" a:anchor="t"/>
-          <a:lstStyle/>
-          <a:p>
-            <a:pPr algn="l"/>
-            <a:r>
-              <a:rPr sz="1600" b="1">
-                <a:solidFill>
-                  <a:srgbClr val="1B2A4A"/>
-                </a:solidFill>
-                <a:latin typeface="Calibri"/>
-              </a:rPr>
-              <a:t>APN Oppt Submission Table</a:t>
-            </a:r>
-          </a:p>
-        </p:txBody>
-      </p:sp>
-      <p:sp>
-        <p:nvSpPr>
-          <p:cNvPr id="8" name="TextBox 7"/>
-          <p:cNvSpPr txBox="1"/>
-          <p:nvPr/>
-        </p:nvSpPr>
-        <p:spPr>
-          <a:xfrm>
-            <a:off x="685800" y="2286000"/>
-            <a:ext cx="5166360" cy="1005840"/>
+            <a:off x="685800" y="2194560"/>
+            <a:ext cx="5166360" cy="1097280"/>
           </a:xfrm>
           <a:prstGeom prst="rect">
             <a:avLst/>
@@ -5525,7 +5228,7 @@
       </p:sp>
       <p:sp>
         <p:nvSpPr>
-          <p:cNvPr id="9" name="Rounded Rectangle 8"/>
+          <p:cNvPr id="8" name="Rounded Rectangle 7"/>
           <p:cNvSpPr/>
           <p:nvPr/>
         </p:nvSpPr>
@@ -5570,80 +5273,47 @@
       </p:sp>
       <p:sp>
         <p:nvSpPr>
+          <p:cNvPr id="9" name="TextBox 8"/>
+          <p:cNvSpPr txBox="1"/>
+          <p:nvPr/>
+        </p:nvSpPr>
+        <p:spPr>
+          <a:xfrm>
+            <a:off x="6537960" y="1554480"/>
+            <a:ext cx="5166360" cy="502920"/>
+          </a:xfrm>
+          <a:prstGeom prst="rect">
+            <a:avLst/>
+          </a:prstGeom>
+          <a:noFill/>
+        </p:spPr>
+        <p:txBody>
+          <a:bodyPr wrap="square" a:anchor="t"/>
+          <a:lstStyle/>
+          <a:p>
+            <a:pPr algn="l"/>
+            <a:r>
+              <a:rPr sz="1600" b="1">
+                <a:solidFill>
+                  <a:srgbClr val="1B2A4A"/>
+                </a:solidFill>
+                <a:latin typeface="Calibri"/>
+              </a:rPr>
+              <a:t>APN Oppt Status Table</a:t>
+            </a:r>
+          </a:p>
+        </p:txBody>
+      </p:sp>
+      <p:sp>
+        <p:nvSpPr>
           <p:cNvPr id="10" name="TextBox 9"/>
           <p:cNvSpPr txBox="1"/>
           <p:nvPr/>
         </p:nvSpPr>
         <p:spPr>
           <a:xfrm>
-            <a:off x="6537960" y="1435608"/>
-            <a:ext cx="5166360" cy="320040"/>
-          </a:xfrm>
-          <a:prstGeom prst="rect">
-            <a:avLst/>
-          </a:prstGeom>
-          <a:noFill/>
-        </p:spPr>
-        <p:txBody>
-          <a:bodyPr wrap="square" a:anchor="t"/>
-          <a:lstStyle/>
-          <a:p>
-            <a:pPr algn="l"/>
-            <a:r>
-              <a:rPr sz="1200" b="1">
-                <a:solidFill>
-                  <a:srgbClr val="E87722"/>
-                </a:solidFill>
-                <a:latin typeface="Calibri"/>
-              </a:rPr>
-              <a:t>02</a:t>
-            </a:r>
-          </a:p>
-        </p:txBody>
-      </p:sp>
-      <p:sp>
-        <p:nvSpPr>
-          <p:cNvPr id="11" name="TextBox 10"/>
-          <p:cNvSpPr txBox="1"/>
-          <p:nvPr/>
-        </p:nvSpPr>
-        <p:spPr>
-          <a:xfrm>
-            <a:off x="6537960" y="1737360"/>
-            <a:ext cx="5166360" cy="502920"/>
-          </a:xfrm>
-          <a:prstGeom prst="rect">
-            <a:avLst/>
-          </a:prstGeom>
-          <a:noFill/>
-        </p:spPr>
-        <p:txBody>
-          <a:bodyPr wrap="square" a:anchor="t"/>
-          <a:lstStyle/>
-          <a:p>
-            <a:pPr algn="l"/>
-            <a:r>
-              <a:rPr sz="1600" b="1">
-                <a:solidFill>
-                  <a:srgbClr val="1B2A4A"/>
-                </a:solidFill>
-                <a:latin typeface="Calibri"/>
-              </a:rPr>
-              <a:t>APN Oppt Status Table</a:t>
-            </a:r>
-          </a:p>
-        </p:txBody>
-      </p:sp>
-      <p:sp>
-        <p:nvSpPr>
-          <p:cNvPr id="12" name="TextBox 11"/>
-          <p:cNvSpPr txBox="1"/>
-          <p:nvPr/>
-        </p:nvSpPr>
-        <p:spPr>
-          <a:xfrm>
-            <a:off x="6537960" y="2286000"/>
-            <a:ext cx="5166360" cy="1005840"/>
+            <a:off x="6537960" y="2194560"/>
+            <a:ext cx="5166360" cy="1097280"/>
           </a:xfrm>
           <a:prstGeom prst="rect">
             <a:avLst/>
@@ -5669,7 +5339,7 @@
       </p:sp>
       <p:sp>
         <p:nvSpPr>
-          <p:cNvPr id="13" name="Rounded Rectangle 12"/>
+          <p:cNvPr id="11" name="Rounded Rectangle 10"/>
           <p:cNvSpPr/>
           <p:nvPr/>
         </p:nvSpPr>
@@ -5714,46 +5384,13 @@
       </p:sp>
       <p:sp>
         <p:nvSpPr>
-          <p:cNvPr id="14" name="TextBox 13"/>
-          <p:cNvSpPr txBox="1"/>
-          <p:nvPr/>
-        </p:nvSpPr>
-        <p:spPr>
-          <a:xfrm>
-            <a:off x="685800" y="3904488"/>
-            <a:ext cx="5166360" cy="320040"/>
-          </a:xfrm>
-          <a:prstGeom prst="rect">
-            <a:avLst/>
-          </a:prstGeom>
-          <a:noFill/>
-        </p:spPr>
-        <p:txBody>
-          <a:bodyPr wrap="square" a:anchor="t"/>
-          <a:lstStyle/>
-          <a:p>
-            <a:pPr algn="l"/>
-            <a:r>
-              <a:rPr sz="1200" b="1">
-                <a:solidFill>
-                  <a:srgbClr val="E87722"/>
-                </a:solidFill>
-                <a:latin typeface="Calibri"/>
-              </a:rPr>
-              <a:t>03</a:t>
-            </a:r>
-          </a:p>
-        </p:txBody>
-      </p:sp>
-      <p:sp>
-        <p:nvSpPr>
-          <p:cNvPr id="15" name="TextBox 14"/>
-          <p:cNvSpPr txBox="1"/>
-          <p:nvPr/>
-        </p:nvSpPr>
-        <p:spPr>
-          <a:xfrm>
-            <a:off x="685800" y="4206240"/>
+          <p:cNvPr id="12" name="TextBox 11"/>
+          <p:cNvSpPr txBox="1"/>
+          <p:nvPr/>
+        </p:nvSpPr>
+        <p:spPr>
+          <a:xfrm>
+            <a:off x="685800" y="4023360"/>
             <a:ext cx="5166360" cy="502920"/>
           </a:xfrm>
           <a:prstGeom prst="rect">
@@ -5780,14 +5417,14 @@
       </p:sp>
       <p:sp>
         <p:nvSpPr>
-          <p:cNvPr id="16" name="TextBox 15"/>
-          <p:cNvSpPr txBox="1"/>
-          <p:nvPr/>
-        </p:nvSpPr>
-        <p:spPr>
-          <a:xfrm>
-            <a:off x="685800" y="4754880"/>
-            <a:ext cx="5166360" cy="1005840"/>
+          <p:cNvPr id="13" name="TextBox 12"/>
+          <p:cNvSpPr txBox="1"/>
+          <p:nvPr/>
+        </p:nvSpPr>
+        <p:spPr>
+          <a:xfrm>
+            <a:off x="685800" y="4663440"/>
+            <a:ext cx="5166360" cy="1097280"/>
           </a:xfrm>
           <a:prstGeom prst="rect">
             <a:avLst/>
@@ -5813,7 +5450,7 @@
       </p:sp>
       <p:sp>
         <p:nvSpPr>
-          <p:cNvPr id="17" name="Rounded Rectangle 16"/>
+          <p:cNvPr id="14" name="Rounded Rectangle 13"/>
           <p:cNvSpPr/>
           <p:nvPr/>
         </p:nvSpPr>
@@ -5858,46 +5495,13 @@
       </p:sp>
       <p:sp>
         <p:nvSpPr>
-          <p:cNvPr id="18" name="TextBox 17"/>
-          <p:cNvSpPr txBox="1"/>
-          <p:nvPr/>
-        </p:nvSpPr>
-        <p:spPr>
-          <a:xfrm>
-            <a:off x="6537960" y="3904488"/>
-            <a:ext cx="5166360" cy="320040"/>
-          </a:xfrm>
-          <a:prstGeom prst="rect">
-            <a:avLst/>
-          </a:prstGeom>
-          <a:noFill/>
-        </p:spPr>
-        <p:txBody>
-          <a:bodyPr wrap="square" a:anchor="t"/>
-          <a:lstStyle/>
-          <a:p>
-            <a:pPr algn="l"/>
-            <a:r>
-              <a:rPr sz="1200" b="1">
-                <a:solidFill>
-                  <a:srgbClr val="E87722"/>
-                </a:solidFill>
-                <a:latin typeface="Calibri"/>
-              </a:rPr>
-              <a:t>04</a:t>
-            </a:r>
-          </a:p>
-        </p:txBody>
-      </p:sp>
-      <p:sp>
-        <p:nvSpPr>
-          <p:cNvPr id="19" name="TextBox 18"/>
-          <p:cNvSpPr txBox="1"/>
-          <p:nvPr/>
-        </p:nvSpPr>
-        <p:spPr>
-          <a:xfrm>
-            <a:off x="6537960" y="4206240"/>
+          <p:cNvPr id="15" name="TextBox 14"/>
+          <p:cNvSpPr txBox="1"/>
+          <p:nvPr/>
+        </p:nvSpPr>
+        <p:spPr>
+          <a:xfrm>
+            <a:off x="6537960" y="4023360"/>
             <a:ext cx="5166360" cy="502920"/>
           </a:xfrm>
           <a:prstGeom prst="rect">
@@ -5924,14 +5528,14 @@
       </p:sp>
       <p:sp>
         <p:nvSpPr>
-          <p:cNvPr id="20" name="TextBox 19"/>
-          <p:cNvSpPr txBox="1"/>
-          <p:nvPr/>
-        </p:nvSpPr>
-        <p:spPr>
-          <a:xfrm>
-            <a:off x="6537960" y="4754880"/>
-            <a:ext cx="5166360" cy="1005840"/>
+          <p:cNvPr id="16" name="TextBox 15"/>
+          <p:cNvSpPr txBox="1"/>
+          <p:nvPr/>
+        </p:nvSpPr>
+        <p:spPr>
+          <a:xfrm>
+            <a:off x="6537960" y="4663440"/>
+            <a:ext cx="5166360" cy="1097280"/>
           </a:xfrm>
           <a:prstGeom prst="rect">
             <a:avLst/>
@@ -5957,14 +5561,14 @@
       </p:sp>
       <p:sp>
         <p:nvSpPr>
-          <p:cNvPr id="21" name="TextBox 20"/>
+          <p:cNvPr id="17" name="TextBox 16"/>
           <p:cNvSpPr txBox="1"/>
           <p:nvPr/>
         </p:nvSpPr>
         <p:spPr>
           <a:xfrm>
             <a:off x="457200" y="6565392"/>
-            <a:ext cx="8686800" cy="219456"/>
+            <a:ext cx="11247120" cy="219456"/>
           </a:xfrm>
           <a:prstGeom prst="rect">
             <a:avLst/>
@@ -5983,40 +5587,7 @@
                 </a:solidFill>
                 <a:latin typeface="Calibri"/>
               </a:rPr>
-              <a:t>GAP-GUIDE-2026-001  ·  Internal  ·  v1.1</a:t>
-            </a:r>
-          </a:p>
-        </p:txBody>
-      </p:sp>
-      <p:sp>
-        <p:nvSpPr>
-          <p:cNvPr id="22" name="TextBox 21"/>
-          <p:cNvSpPr txBox="1"/>
-          <p:nvPr/>
-        </p:nvSpPr>
-        <p:spPr>
-          <a:xfrm>
-            <a:off x="9509760" y="6565392"/>
-            <a:ext cx="2194560" cy="219456"/>
-          </a:xfrm>
-          <a:prstGeom prst="rect">
-            <a:avLst/>
-          </a:prstGeom>
-          <a:noFill/>
-        </p:spPr>
-        <p:txBody>
-          <a:bodyPr wrap="square" a:anchor="t"/>
-          <a:lstStyle/>
-          <a:p>
-            <a:pPr algn="r"/>
-            <a:r>
-              <a:rPr sz="1000" b="0">
-                <a:solidFill>
-                  <a:srgbClr val="8A8478"/>
-                </a:solidFill>
-                <a:latin typeface="Calibri"/>
-              </a:rPr>
-              <a:t>3 / 12</a:t>
+              <a:t>Internal  ·  v1.1  ·  © G-AsiaPacific</a:t>
             </a:r>
           </a:p>
         </p:txBody>
@@ -6110,7 +5681,7 @@
                 </a:solidFill>
                 <a:latin typeface="Calibri"/>
               </a:rPr>
-              <a:t>4. WHICH JOB?</a:t>
+              <a:t>WHICH JOB?</a:t>
             </a:r>
           </a:p>
         </p:txBody>
@@ -6221,7 +5792,7 @@
                 </a:solidFill>
                 <a:latin typeface="Calibri"/>
               </a:rPr>
-              <a:t>1a  Draft</a:t>
+              <a:t>Draft</a:t>
             </a:r>
           </a:p>
         </p:txBody>
@@ -6366,7 +5937,7 @@
                 </a:solidFill>
                 <a:latin typeface="Calibri"/>
               </a:rPr>
-              <a:t>1b  Send</a:t>
+              <a:t>Send</a:t>
             </a:r>
           </a:p>
         </p:txBody>
@@ -6511,7 +6082,7 @@
                 </a:solidFill>
                 <a:latin typeface="Calibri"/>
               </a:rPr>
-              <a:t>2  Change</a:t>
+              <a:t>Change</a:t>
             </a:r>
           </a:p>
         </p:txBody>
@@ -6656,7 +6227,7 @@
                 </a:solidFill>
                 <a:latin typeface="Calibri"/>
               </a:rPr>
-              <a:t>3  Referral</a:t>
+              <a:t>Referral</a:t>
             </a:r>
           </a:p>
         </p:txBody>
@@ -6794,7 +6365,7 @@
         <p:spPr>
           <a:xfrm>
             <a:off x="457200" y="6565392"/>
-            <a:ext cx="8686800" cy="219456"/>
+            <a:ext cx="11247120" cy="219456"/>
           </a:xfrm>
           <a:prstGeom prst="rect">
             <a:avLst/>
@@ -6813,40 +6384,7 @@
                 </a:solidFill>
                 <a:latin typeface="Calibri"/>
               </a:rPr>
-              <a:t>GAP-GUIDE-2026-001  ·  Internal  ·  v1.1</a:t>
-            </a:r>
-          </a:p>
-        </p:txBody>
-      </p:sp>
-      <p:sp>
-        <p:nvSpPr>
-          <p:cNvPr id="24" name="TextBox 23"/>
-          <p:cNvSpPr txBox="1"/>
-          <p:nvPr/>
-        </p:nvSpPr>
-        <p:spPr>
-          <a:xfrm>
-            <a:off x="9509760" y="6565392"/>
-            <a:ext cx="2194560" cy="219456"/>
-          </a:xfrm>
-          <a:prstGeom prst="rect">
-            <a:avLst/>
-          </a:prstGeom>
-          <a:noFill/>
-        </p:spPr>
-        <p:txBody>
-          <a:bodyPr wrap="square" a:anchor="t"/>
-          <a:lstStyle/>
-          <a:p>
-            <a:pPr algn="r"/>
-            <a:r>
-              <a:rPr sz="1000" b="0">
-                <a:solidFill>
-                  <a:srgbClr val="8A8478"/>
-                </a:solidFill>
-                <a:latin typeface="Calibri"/>
-              </a:rPr>
-              <a:t>4 / 12</a:t>
+              <a:t>Internal  ·  v1.1  ·  © G-AsiaPacific</a:t>
             </a:r>
           </a:p>
         </p:txBody>
@@ -6940,7 +6478,7 @@
                 </a:solidFill>
                 <a:latin typeface="Calibri"/>
               </a:rPr>
-              <a:t>5.2  DRAFT — GRID + ADD RECORD</a:t>
+              <a:t>DRAFT — GRID + ADD RECORD</a:t>
             </a:r>
           </a:p>
         </p:txBody>
@@ -7079,41 +6617,8 @@
         </p:nvSpPr>
         <p:spPr>
           <a:xfrm>
-            <a:off x="7223760" y="1307592"/>
-            <a:ext cx="365760" cy="274320"/>
-          </a:xfrm>
-          <a:prstGeom prst="rect">
-            <a:avLst/>
-          </a:prstGeom>
-          <a:noFill/>
-        </p:spPr>
-        <p:txBody>
-          <a:bodyPr wrap="square" a:anchor="t"/>
-          <a:lstStyle/>
-          <a:p>
-            <a:pPr algn="l"/>
-            <a:r>
-              <a:rPr sz="1400" b="1">
-                <a:solidFill>
-                  <a:srgbClr val="E87722"/>
-                </a:solidFill>
-                <a:latin typeface="Calibri"/>
-              </a:rPr>
-              <a:t>1</a:t>
-            </a:r>
-          </a:p>
-        </p:txBody>
-      </p:sp>
-      <p:sp>
-        <p:nvSpPr>
-          <p:cNvPr id="9" name="TextBox 8"/>
-          <p:cNvSpPr txBox="1"/>
-          <p:nvPr/>
-        </p:nvSpPr>
-        <p:spPr>
-          <a:xfrm>
-            <a:off x="7589520" y="1325880"/>
-            <a:ext cx="3977639" cy="685800"/>
+            <a:off x="7269480" y="1344168"/>
+            <a:ext cx="4297680" cy="685800"/>
           </a:xfrm>
           <a:prstGeom prst="rect">
             <a:avLst/>
@@ -7139,7 +6644,7 @@
       </p:sp>
       <p:sp>
         <p:nvSpPr>
-          <p:cNvPr id="10" name="Rounded Rectangle 9"/>
+          <p:cNvPr id="9" name="Rounded Rectangle 8"/>
           <p:cNvSpPr/>
           <p:nvPr/>
         </p:nvSpPr>
@@ -7184,47 +6689,14 @@
       </p:sp>
       <p:sp>
         <p:nvSpPr>
-          <p:cNvPr id="11" name="TextBox 10"/>
-          <p:cNvSpPr txBox="1"/>
-          <p:nvPr/>
-        </p:nvSpPr>
-        <p:spPr>
-          <a:xfrm>
-            <a:off x="7223760" y="2240280"/>
-            <a:ext cx="365760" cy="274320"/>
-          </a:xfrm>
-          <a:prstGeom prst="rect">
-            <a:avLst/>
-          </a:prstGeom>
-          <a:noFill/>
-        </p:spPr>
-        <p:txBody>
-          <a:bodyPr wrap="square" a:anchor="t"/>
-          <a:lstStyle/>
-          <a:p>
-            <a:pPr algn="l"/>
-            <a:r>
-              <a:rPr sz="1400" b="1">
-                <a:solidFill>
-                  <a:srgbClr val="E87722"/>
-                </a:solidFill>
-                <a:latin typeface="Calibri"/>
-              </a:rPr>
-              <a:t>2</a:t>
-            </a:r>
-          </a:p>
-        </p:txBody>
-      </p:sp>
-      <p:sp>
-        <p:nvSpPr>
-          <p:cNvPr id="12" name="TextBox 11"/>
-          <p:cNvSpPr txBox="1"/>
-          <p:nvPr/>
-        </p:nvSpPr>
-        <p:spPr>
-          <a:xfrm>
-            <a:off x="7589520" y="2258568"/>
-            <a:ext cx="3977639" cy="685800"/>
+          <p:cNvPr id="10" name="TextBox 9"/>
+          <p:cNvSpPr txBox="1"/>
+          <p:nvPr/>
+        </p:nvSpPr>
+        <p:spPr>
+          <a:xfrm>
+            <a:off x="7269480" y="2276856"/>
+            <a:ext cx="4297680" cy="685800"/>
           </a:xfrm>
           <a:prstGeom prst="rect">
             <a:avLst/>
@@ -7250,7 +6722,7 @@
       </p:sp>
       <p:sp>
         <p:nvSpPr>
-          <p:cNvPr id="13" name="Rounded Rectangle 12"/>
+          <p:cNvPr id="11" name="Rounded Rectangle 10"/>
           <p:cNvSpPr/>
           <p:nvPr/>
         </p:nvSpPr>
@@ -7295,47 +6767,14 @@
       </p:sp>
       <p:sp>
         <p:nvSpPr>
-          <p:cNvPr id="14" name="TextBox 13"/>
-          <p:cNvSpPr txBox="1"/>
-          <p:nvPr/>
-        </p:nvSpPr>
-        <p:spPr>
-          <a:xfrm>
-            <a:off x="7223760" y="3172968"/>
-            <a:ext cx="365760" cy="274320"/>
-          </a:xfrm>
-          <a:prstGeom prst="rect">
-            <a:avLst/>
-          </a:prstGeom>
-          <a:noFill/>
-        </p:spPr>
-        <p:txBody>
-          <a:bodyPr wrap="square" a:anchor="t"/>
-          <a:lstStyle/>
-          <a:p>
-            <a:pPr algn="l"/>
-            <a:r>
-              <a:rPr sz="1400" b="1">
-                <a:solidFill>
-                  <a:srgbClr val="E87722"/>
-                </a:solidFill>
-                <a:latin typeface="Calibri"/>
-              </a:rPr>
-              <a:t>3</a:t>
-            </a:r>
-          </a:p>
-        </p:txBody>
-      </p:sp>
-      <p:sp>
-        <p:nvSpPr>
-          <p:cNvPr id="15" name="TextBox 14"/>
-          <p:cNvSpPr txBox="1"/>
-          <p:nvPr/>
-        </p:nvSpPr>
-        <p:spPr>
-          <a:xfrm>
-            <a:off x="7589520" y="3191256"/>
-            <a:ext cx="3977639" cy="685800"/>
+          <p:cNvPr id="12" name="TextBox 11"/>
+          <p:cNvSpPr txBox="1"/>
+          <p:nvPr/>
+        </p:nvSpPr>
+        <p:spPr>
+          <a:xfrm>
+            <a:off x="7269480" y="3209544"/>
+            <a:ext cx="4297680" cy="685800"/>
           </a:xfrm>
           <a:prstGeom prst="rect">
             <a:avLst/>
@@ -7361,7 +6800,7 @@
       </p:sp>
       <p:sp>
         <p:nvSpPr>
-          <p:cNvPr id="16" name="Rounded Rectangle 15"/>
+          <p:cNvPr id="13" name="Rounded Rectangle 12"/>
           <p:cNvSpPr/>
           <p:nvPr/>
         </p:nvSpPr>
@@ -7406,47 +6845,14 @@
       </p:sp>
       <p:sp>
         <p:nvSpPr>
-          <p:cNvPr id="17" name="TextBox 16"/>
-          <p:cNvSpPr txBox="1"/>
-          <p:nvPr/>
-        </p:nvSpPr>
-        <p:spPr>
-          <a:xfrm>
-            <a:off x="7223760" y="4105656"/>
-            <a:ext cx="365760" cy="274320"/>
-          </a:xfrm>
-          <a:prstGeom prst="rect">
-            <a:avLst/>
-          </a:prstGeom>
-          <a:noFill/>
-        </p:spPr>
-        <p:txBody>
-          <a:bodyPr wrap="square" a:anchor="t"/>
-          <a:lstStyle/>
-          <a:p>
-            <a:pPr algn="l"/>
-            <a:r>
-              <a:rPr sz="1400" b="1">
-                <a:solidFill>
-                  <a:srgbClr val="E87722"/>
-                </a:solidFill>
-                <a:latin typeface="Calibri"/>
-              </a:rPr>
-              <a:t>4</a:t>
-            </a:r>
-          </a:p>
-        </p:txBody>
-      </p:sp>
-      <p:sp>
-        <p:nvSpPr>
-          <p:cNvPr id="18" name="TextBox 17"/>
-          <p:cNvSpPr txBox="1"/>
-          <p:nvPr/>
-        </p:nvSpPr>
-        <p:spPr>
-          <a:xfrm>
-            <a:off x="7589520" y="4123944"/>
-            <a:ext cx="3977639" cy="685800"/>
+          <p:cNvPr id="14" name="TextBox 13"/>
+          <p:cNvSpPr txBox="1"/>
+          <p:nvPr/>
+        </p:nvSpPr>
+        <p:spPr>
+          <a:xfrm>
+            <a:off x="7269480" y="4142232"/>
+            <a:ext cx="4297680" cy="685800"/>
           </a:xfrm>
           <a:prstGeom prst="rect">
             <a:avLst/>
@@ -7472,7 +6878,7 @@
       </p:sp>
       <p:sp>
         <p:nvSpPr>
-          <p:cNvPr id="19" name="Rounded Rectangle 18"/>
+          <p:cNvPr id="15" name="Rounded Rectangle 14"/>
           <p:cNvSpPr/>
           <p:nvPr/>
         </p:nvSpPr>
@@ -7517,47 +6923,14 @@
       </p:sp>
       <p:sp>
         <p:nvSpPr>
-          <p:cNvPr id="20" name="TextBox 19"/>
-          <p:cNvSpPr txBox="1"/>
-          <p:nvPr/>
-        </p:nvSpPr>
-        <p:spPr>
-          <a:xfrm>
-            <a:off x="7223760" y="5038344"/>
-            <a:ext cx="365760" cy="274320"/>
-          </a:xfrm>
-          <a:prstGeom prst="rect">
-            <a:avLst/>
-          </a:prstGeom>
-          <a:noFill/>
-        </p:spPr>
-        <p:txBody>
-          <a:bodyPr wrap="square" a:anchor="t"/>
-          <a:lstStyle/>
-          <a:p>
-            <a:pPr algn="l"/>
-            <a:r>
-              <a:rPr sz="1400" b="1">
-                <a:solidFill>
-                  <a:srgbClr val="E87722"/>
-                </a:solidFill>
-                <a:latin typeface="Calibri"/>
-              </a:rPr>
-              <a:t>5</a:t>
-            </a:r>
-          </a:p>
-        </p:txBody>
-      </p:sp>
-      <p:sp>
-        <p:nvSpPr>
-          <p:cNvPr id="21" name="TextBox 20"/>
-          <p:cNvSpPr txBox="1"/>
-          <p:nvPr/>
-        </p:nvSpPr>
-        <p:spPr>
-          <a:xfrm>
-            <a:off x="7589520" y="5056632"/>
-            <a:ext cx="3977639" cy="685800"/>
+          <p:cNvPr id="16" name="TextBox 15"/>
+          <p:cNvSpPr txBox="1"/>
+          <p:nvPr/>
+        </p:nvSpPr>
+        <p:spPr>
+          <a:xfrm>
+            <a:off x="7269480" y="5074920"/>
+            <a:ext cx="4297680" cy="685800"/>
           </a:xfrm>
           <a:prstGeom prst="rect">
             <a:avLst/>
@@ -7583,14 +6956,14 @@
       </p:sp>
       <p:sp>
         <p:nvSpPr>
-          <p:cNvPr id="22" name="TextBox 21"/>
+          <p:cNvPr id="17" name="TextBox 16"/>
           <p:cNvSpPr txBox="1"/>
           <p:nvPr/>
         </p:nvSpPr>
         <p:spPr>
           <a:xfrm>
             <a:off x="457200" y="6565392"/>
-            <a:ext cx="8686800" cy="219456"/>
+            <a:ext cx="11247120" cy="219456"/>
           </a:xfrm>
           <a:prstGeom prst="rect">
             <a:avLst/>
@@ -7609,40 +6982,7 @@
                 </a:solidFill>
                 <a:latin typeface="Calibri"/>
               </a:rPr>
-              <a:t>GAP-GUIDE-2026-001  ·  Internal  ·  v1.1</a:t>
-            </a:r>
-          </a:p>
-        </p:txBody>
-      </p:sp>
-      <p:sp>
-        <p:nvSpPr>
-          <p:cNvPr id="23" name="TextBox 22"/>
-          <p:cNvSpPr txBox="1"/>
-          <p:nvPr/>
-        </p:nvSpPr>
-        <p:spPr>
-          <a:xfrm>
-            <a:off x="9509760" y="6565392"/>
-            <a:ext cx="2194560" cy="219456"/>
-          </a:xfrm>
-          <a:prstGeom prst="rect">
-            <a:avLst/>
-          </a:prstGeom>
-          <a:noFill/>
-        </p:spPr>
-        <p:txBody>
-          <a:bodyPr wrap="square" a:anchor="t"/>
-          <a:lstStyle/>
-          <a:p>
-            <a:pPr algn="r"/>
-            <a:r>
-              <a:rPr sz="1000" b="0">
-                <a:solidFill>
-                  <a:srgbClr val="8A8478"/>
-                </a:solidFill>
-                <a:latin typeface="Calibri"/>
-              </a:rPr>
-              <a:t>5 / 12</a:t>
+              <a:t>Internal  ·  v1.1  ·  © G-AsiaPacific</a:t>
             </a:r>
           </a:p>
         </p:txBody>
@@ -7736,7 +7076,7 @@
                 </a:solidFill>
                 <a:latin typeface="Calibri"/>
               </a:rPr>
-              <a:t>5.1  SEND NOW — FORM</a:t>
+              <a:t>SEND NOW — FORM</a:t>
             </a:r>
           </a:p>
         </p:txBody>
@@ -7871,7 +7211,7 @@
                 </a:solidFill>
                 <a:latin typeface="Calibri"/>
               </a:rPr>
-              <a:t>1  Form</a:t>
+              <a:t>Form</a:t>
             </a:r>
           </a:p>
         </p:txBody>
@@ -7904,7 +7244,7 @@
                 </a:solidFill>
                 <a:latin typeface="Calibri"/>
               </a:rPr>
-              <a:t>Use Fill, not Edit. Fill required fields. Section 9 format.</a:t>
+              <a:t>Use Fill, not Edit. Fill required fields. Follow the format rules.</a:t>
             </a:r>
           </a:p>
         </p:txBody>
@@ -7982,7 +7322,7 @@
                 </a:solidFill>
                 <a:latin typeface="Calibri"/>
               </a:rPr>
-              <a:t>2  Submit</a:t>
+              <a:t>Submit</a:t>
             </a:r>
           </a:p>
         </p:txBody>
@@ -8093,7 +7433,7 @@
                 </a:solidFill>
                 <a:latin typeface="Calibri"/>
               </a:rPr>
-              <a:t>3  1 minute</a:t>
+              <a:t>Wait one minute</a:t>
             </a:r>
           </a:p>
         </p:txBody>
@@ -8251,7 +7591,7 @@
         <p:spPr>
           <a:xfrm>
             <a:off x="457200" y="6565392"/>
-            <a:ext cx="8686800" cy="219456"/>
+            <a:ext cx="11247120" cy="219456"/>
           </a:xfrm>
           <a:prstGeom prst="rect">
             <a:avLst/>
@@ -8270,40 +7610,7 @@
                 </a:solidFill>
                 <a:latin typeface="Calibri"/>
               </a:rPr>
-              <a:t>GAP-GUIDE-2026-001  ·  Internal  ·  v1.1</a:t>
-            </a:r>
-          </a:p>
-        </p:txBody>
-      </p:sp>
-      <p:sp>
-        <p:nvSpPr>
-          <p:cNvPr id="19" name="TextBox 18"/>
-          <p:cNvSpPr txBox="1"/>
-          <p:nvPr/>
-        </p:nvSpPr>
-        <p:spPr>
-          <a:xfrm>
-            <a:off x="9509760" y="6565392"/>
-            <a:ext cx="2194560" cy="219456"/>
-          </a:xfrm>
-          <a:prstGeom prst="rect">
-            <a:avLst/>
-          </a:prstGeom>
-          <a:noFill/>
-        </p:spPr>
-        <p:txBody>
-          <a:bodyPr wrap="square" a:anchor="t"/>
-          <a:lstStyle/>
-          <a:p>
-            <a:pPr algn="r"/>
-            <a:r>
-              <a:rPr sz="1000" b="0">
-                <a:solidFill>
-                  <a:srgbClr val="8A8478"/>
-                </a:solidFill>
-                <a:latin typeface="Calibri"/>
-              </a:rPr>
-              <a:t>6 / 12</a:t>
+              <a:t>Internal  ·  v1.1  ·  © G-AsiaPacific</a:t>
             </a:r>
           </a:p>
         </p:txBody>
@@ -8397,7 +7704,7 @@
                 </a:solidFill>
                 <a:latin typeface="Calibri"/>
               </a:rPr>
-              <a:t>6. UPDATE</a:t>
+              <a:t>UPDATE</a:t>
             </a:r>
           </a:p>
         </p:txBody>
@@ -8912,7 +8219,7 @@
         <p:spPr>
           <a:xfrm>
             <a:off x="457200" y="6565392"/>
-            <a:ext cx="8686800" cy="219456"/>
+            <a:ext cx="11247120" cy="219456"/>
           </a:xfrm>
           <a:prstGeom prst="rect">
             <a:avLst/>
@@ -8931,40 +8238,7 @@
                 </a:solidFill>
                 <a:latin typeface="Calibri"/>
               </a:rPr>
-              <a:t>GAP-GUIDE-2026-001  ·  Internal  ·  v1.1</a:t>
-            </a:r>
-          </a:p>
-        </p:txBody>
-      </p:sp>
-      <p:sp>
-        <p:nvSpPr>
-          <p:cNvPr id="19" name="TextBox 18"/>
-          <p:cNvSpPr txBox="1"/>
-          <p:nvPr/>
-        </p:nvSpPr>
-        <p:spPr>
-          <a:xfrm>
-            <a:off x="9509760" y="6565392"/>
-            <a:ext cx="2194560" cy="219456"/>
-          </a:xfrm>
-          <a:prstGeom prst="rect">
-            <a:avLst/>
-          </a:prstGeom>
-          <a:noFill/>
-        </p:spPr>
-        <p:txBody>
-          <a:bodyPr wrap="square" a:anchor="t"/>
-          <a:lstStyle/>
-          <a:p>
-            <a:pPr algn="r"/>
-            <a:r>
-              <a:rPr sz="1000" b="0">
-                <a:solidFill>
-                  <a:srgbClr val="8A8478"/>
-                </a:solidFill>
-                <a:latin typeface="Calibri"/>
-              </a:rPr>
-              <a:t>7 / 12</a:t>
+              <a:t>Internal  ·  v1.1  ·  © G-AsiaPacific</a:t>
             </a:r>
           </a:p>
         </p:txBody>
@@ -9058,7 +8332,7 @@
                 </a:solidFill>
                 <a:latin typeface="Calibri"/>
               </a:rPr>
-              <a:t>7. REFERRAL — SALES ADMIN</a:t>
+              <a:t>REFERRAL — SALES ADMIN</a:t>
             </a:r>
           </a:p>
         </p:txBody>
@@ -9173,41 +8447,8 @@
         </p:nvSpPr>
         <p:spPr>
           <a:xfrm>
-            <a:off x="5760720" y="1353312"/>
-            <a:ext cx="365760" cy="365760"/>
-          </a:xfrm>
-          <a:prstGeom prst="rect">
-            <a:avLst/>
-          </a:prstGeom>
-          <a:noFill/>
-        </p:spPr>
-        <p:txBody>
-          <a:bodyPr wrap="square" a:anchor="t"/>
-          <a:lstStyle/>
-          <a:p>
-            <a:pPr algn="l"/>
-            <a:r>
-              <a:rPr sz="1400" b="1">
-                <a:solidFill>
-                  <a:srgbClr val="E87722"/>
-                </a:solidFill>
-                <a:latin typeface="Calibri"/>
-              </a:rPr>
-              <a:t>1</a:t>
-            </a:r>
-          </a:p>
-        </p:txBody>
-      </p:sp>
-      <p:sp>
-        <p:nvSpPr>
-          <p:cNvPr id="8" name="TextBox 7"/>
-          <p:cNvSpPr txBox="1"/>
-          <p:nvPr/>
-        </p:nvSpPr>
-        <p:spPr>
-          <a:xfrm>
-            <a:off x="6172200" y="1353312"/>
-            <a:ext cx="5394960" cy="457200"/>
+            <a:off x="5852160" y="1353312"/>
+            <a:ext cx="5715000" cy="457200"/>
           </a:xfrm>
           <a:prstGeom prst="rect">
             <a:avLst/>
@@ -9233,7 +8474,7 @@
       </p:sp>
       <p:sp>
         <p:nvSpPr>
-          <p:cNvPr id="9" name="Rounded Rectangle 8"/>
+          <p:cNvPr id="8" name="Rounded Rectangle 7"/>
           <p:cNvSpPr/>
           <p:nvPr/>
         </p:nvSpPr>
@@ -9278,47 +8519,14 @@
       </p:sp>
       <p:sp>
         <p:nvSpPr>
-          <p:cNvPr id="10" name="TextBox 9"/>
-          <p:cNvSpPr txBox="1"/>
-          <p:nvPr/>
-        </p:nvSpPr>
-        <p:spPr>
-          <a:xfrm>
-            <a:off x="5760720" y="2130552"/>
-            <a:ext cx="365760" cy="365760"/>
-          </a:xfrm>
-          <a:prstGeom prst="rect">
-            <a:avLst/>
-          </a:prstGeom>
-          <a:noFill/>
-        </p:spPr>
-        <p:txBody>
-          <a:bodyPr wrap="square" a:anchor="t"/>
-          <a:lstStyle/>
-          <a:p>
-            <a:pPr algn="l"/>
-            <a:r>
-              <a:rPr sz="1400" b="1">
-                <a:solidFill>
-                  <a:srgbClr val="E87722"/>
-                </a:solidFill>
-                <a:latin typeface="Calibri"/>
-              </a:rPr>
-              <a:t>2</a:t>
-            </a:r>
-          </a:p>
-        </p:txBody>
-      </p:sp>
-      <p:sp>
-        <p:nvSpPr>
-          <p:cNvPr id="11" name="TextBox 10"/>
-          <p:cNvSpPr txBox="1"/>
-          <p:nvPr/>
-        </p:nvSpPr>
-        <p:spPr>
-          <a:xfrm>
-            <a:off x="6172200" y="2130552"/>
-            <a:ext cx="5394960" cy="457200"/>
+          <p:cNvPr id="9" name="TextBox 8"/>
+          <p:cNvSpPr txBox="1"/>
+          <p:nvPr/>
+        </p:nvSpPr>
+        <p:spPr>
+          <a:xfrm>
+            <a:off x="5852160" y="2130552"/>
+            <a:ext cx="5715000" cy="457200"/>
           </a:xfrm>
           <a:prstGeom prst="rect">
             <a:avLst/>
@@ -9344,7 +8552,7 @@
       </p:sp>
       <p:sp>
         <p:nvSpPr>
-          <p:cNvPr id="12" name="Rounded Rectangle 11"/>
+          <p:cNvPr id="10" name="Rounded Rectangle 9"/>
           <p:cNvSpPr/>
           <p:nvPr/>
         </p:nvSpPr>
@@ -9389,47 +8597,14 @@
       </p:sp>
       <p:sp>
         <p:nvSpPr>
-          <p:cNvPr id="13" name="TextBox 12"/>
-          <p:cNvSpPr txBox="1"/>
-          <p:nvPr/>
-        </p:nvSpPr>
-        <p:spPr>
-          <a:xfrm>
-            <a:off x="5760720" y="2907792"/>
-            <a:ext cx="365760" cy="365760"/>
-          </a:xfrm>
-          <a:prstGeom prst="rect">
-            <a:avLst/>
-          </a:prstGeom>
-          <a:noFill/>
-        </p:spPr>
-        <p:txBody>
-          <a:bodyPr wrap="square" a:anchor="t"/>
-          <a:lstStyle/>
-          <a:p>
-            <a:pPr algn="l"/>
-            <a:r>
-              <a:rPr sz="1400" b="1">
-                <a:solidFill>
-                  <a:srgbClr val="E87722"/>
-                </a:solidFill>
-                <a:latin typeface="Calibri"/>
-              </a:rPr>
-              <a:t>3</a:t>
-            </a:r>
-          </a:p>
-        </p:txBody>
-      </p:sp>
-      <p:sp>
-        <p:nvSpPr>
-          <p:cNvPr id="14" name="TextBox 13"/>
-          <p:cNvSpPr txBox="1"/>
-          <p:nvPr/>
-        </p:nvSpPr>
-        <p:spPr>
-          <a:xfrm>
-            <a:off x="6172200" y="2907792"/>
-            <a:ext cx="5394960" cy="457200"/>
+          <p:cNvPr id="11" name="TextBox 10"/>
+          <p:cNvSpPr txBox="1"/>
+          <p:nvPr/>
+        </p:nvSpPr>
+        <p:spPr>
+          <a:xfrm>
+            <a:off x="5852160" y="2907792"/>
+            <a:ext cx="5715000" cy="457200"/>
           </a:xfrm>
           <a:prstGeom prst="rect">
             <a:avLst/>
@@ -9455,7 +8630,7 @@
       </p:sp>
       <p:sp>
         <p:nvSpPr>
-          <p:cNvPr id="15" name="Rounded Rectangle 14"/>
+          <p:cNvPr id="12" name="Rounded Rectangle 11"/>
           <p:cNvSpPr/>
           <p:nvPr/>
         </p:nvSpPr>
@@ -9500,47 +8675,14 @@
       </p:sp>
       <p:sp>
         <p:nvSpPr>
-          <p:cNvPr id="16" name="TextBox 15"/>
-          <p:cNvSpPr txBox="1"/>
-          <p:nvPr/>
-        </p:nvSpPr>
-        <p:spPr>
-          <a:xfrm>
-            <a:off x="5760720" y="3685032"/>
-            <a:ext cx="365760" cy="365760"/>
-          </a:xfrm>
-          <a:prstGeom prst="rect">
-            <a:avLst/>
-          </a:prstGeom>
-          <a:noFill/>
-        </p:spPr>
-        <p:txBody>
-          <a:bodyPr wrap="square" a:anchor="t"/>
-          <a:lstStyle/>
-          <a:p>
-            <a:pPr algn="l"/>
-            <a:r>
-              <a:rPr sz="1400" b="1">
-                <a:solidFill>
-                  <a:srgbClr val="E87722"/>
-                </a:solidFill>
-                <a:latin typeface="Calibri"/>
-              </a:rPr>
-              <a:t>4</a:t>
-            </a:r>
-          </a:p>
-        </p:txBody>
-      </p:sp>
-      <p:sp>
-        <p:nvSpPr>
-          <p:cNvPr id="17" name="TextBox 16"/>
-          <p:cNvSpPr txBox="1"/>
-          <p:nvPr/>
-        </p:nvSpPr>
-        <p:spPr>
-          <a:xfrm>
-            <a:off x="6172200" y="3685032"/>
-            <a:ext cx="5394960" cy="457200"/>
+          <p:cNvPr id="13" name="TextBox 12"/>
+          <p:cNvSpPr txBox="1"/>
+          <p:nvPr/>
+        </p:nvSpPr>
+        <p:spPr>
+          <a:xfrm>
+            <a:off x="5852160" y="3685032"/>
+            <a:ext cx="5715000" cy="457200"/>
           </a:xfrm>
           <a:prstGeom prst="rect">
             <a:avLst/>
@@ -9566,7 +8708,7 @@
       </p:sp>
       <p:sp>
         <p:nvSpPr>
-          <p:cNvPr id="18" name="Rounded Rectangle 17"/>
+          <p:cNvPr id="14" name="Rounded Rectangle 13"/>
           <p:cNvSpPr/>
           <p:nvPr/>
         </p:nvSpPr>
@@ -9611,47 +8753,14 @@
       </p:sp>
       <p:sp>
         <p:nvSpPr>
-          <p:cNvPr id="19" name="TextBox 18"/>
-          <p:cNvSpPr txBox="1"/>
-          <p:nvPr/>
-        </p:nvSpPr>
-        <p:spPr>
-          <a:xfrm>
-            <a:off x="5760720" y="4462272"/>
-            <a:ext cx="365760" cy="365760"/>
-          </a:xfrm>
-          <a:prstGeom prst="rect">
-            <a:avLst/>
-          </a:prstGeom>
-          <a:noFill/>
-        </p:spPr>
-        <p:txBody>
-          <a:bodyPr wrap="square" a:anchor="t"/>
-          <a:lstStyle/>
-          <a:p>
-            <a:pPr algn="l"/>
-            <a:r>
-              <a:rPr sz="1400" b="1">
-                <a:solidFill>
-                  <a:srgbClr val="E87722"/>
-                </a:solidFill>
-                <a:latin typeface="Calibri"/>
-              </a:rPr>
-              <a:t>5</a:t>
-            </a:r>
-          </a:p>
-        </p:txBody>
-      </p:sp>
-      <p:sp>
-        <p:nvSpPr>
-          <p:cNvPr id="20" name="TextBox 19"/>
-          <p:cNvSpPr txBox="1"/>
-          <p:nvPr/>
-        </p:nvSpPr>
-        <p:spPr>
-          <a:xfrm>
-            <a:off x="6172200" y="4462272"/>
-            <a:ext cx="5394960" cy="457200"/>
+          <p:cNvPr id="15" name="TextBox 14"/>
+          <p:cNvSpPr txBox="1"/>
+          <p:nvPr/>
+        </p:nvSpPr>
+        <p:spPr>
+          <a:xfrm>
+            <a:off x="5852160" y="4462272"/>
+            <a:ext cx="5715000" cy="457200"/>
           </a:xfrm>
           <a:prstGeom prst="rect">
             <a:avLst/>
@@ -9677,7 +8786,7 @@
       </p:sp>
       <p:sp>
         <p:nvSpPr>
-          <p:cNvPr id="21" name="Rounded Rectangle 20"/>
+          <p:cNvPr id="16" name="Rounded Rectangle 15"/>
           <p:cNvSpPr/>
           <p:nvPr/>
         </p:nvSpPr>
@@ -9722,47 +8831,14 @@
       </p:sp>
       <p:sp>
         <p:nvSpPr>
-          <p:cNvPr id="22" name="TextBox 21"/>
-          <p:cNvSpPr txBox="1"/>
-          <p:nvPr/>
-        </p:nvSpPr>
-        <p:spPr>
-          <a:xfrm>
-            <a:off x="5760720" y="5239512"/>
-            <a:ext cx="365760" cy="365760"/>
-          </a:xfrm>
-          <a:prstGeom prst="rect">
-            <a:avLst/>
-          </a:prstGeom>
-          <a:noFill/>
-        </p:spPr>
-        <p:txBody>
-          <a:bodyPr wrap="square" a:anchor="t"/>
-          <a:lstStyle/>
-          <a:p>
-            <a:pPr algn="l"/>
-            <a:r>
-              <a:rPr sz="1400" b="1">
-                <a:solidFill>
-                  <a:srgbClr val="E87722"/>
-                </a:solidFill>
-                <a:latin typeface="Calibri"/>
-              </a:rPr>
-              <a:t>6</a:t>
-            </a:r>
-          </a:p>
-        </p:txBody>
-      </p:sp>
-      <p:sp>
-        <p:nvSpPr>
-          <p:cNvPr id="23" name="TextBox 22"/>
-          <p:cNvSpPr txBox="1"/>
-          <p:nvPr/>
-        </p:nvSpPr>
-        <p:spPr>
-          <a:xfrm>
-            <a:off x="6172200" y="5239512"/>
-            <a:ext cx="5394960" cy="457200"/>
+          <p:cNvPr id="17" name="TextBox 16"/>
+          <p:cNvSpPr txBox="1"/>
+          <p:nvPr/>
+        </p:nvSpPr>
+        <p:spPr>
+          <a:xfrm>
+            <a:off x="5852160" y="5239512"/>
+            <a:ext cx="5715000" cy="457200"/>
           </a:xfrm>
           <a:prstGeom prst="rect">
             <a:avLst/>
@@ -9788,14 +8864,14 @@
       </p:sp>
       <p:sp>
         <p:nvSpPr>
-          <p:cNvPr id="24" name="TextBox 23"/>
+          <p:cNvPr id="18" name="TextBox 17"/>
           <p:cNvSpPr txBox="1"/>
           <p:nvPr/>
         </p:nvSpPr>
         <p:spPr>
           <a:xfrm>
             <a:off x="457200" y="6565392"/>
-            <a:ext cx="8686800" cy="219456"/>
+            <a:ext cx="11247120" cy="219456"/>
           </a:xfrm>
           <a:prstGeom prst="rect">
             <a:avLst/>
@@ -9814,40 +8890,7 @@
                 </a:solidFill>
                 <a:latin typeface="Calibri"/>
               </a:rPr>
-              <a:t>GAP-GUIDE-2026-001  ·  Internal  ·  v1.1</a:t>
-            </a:r>
-          </a:p>
-        </p:txBody>
-      </p:sp>
-      <p:sp>
-        <p:nvSpPr>
-          <p:cNvPr id="25" name="TextBox 24"/>
-          <p:cNvSpPr txBox="1"/>
-          <p:nvPr/>
-        </p:nvSpPr>
-        <p:spPr>
-          <a:xfrm>
-            <a:off x="9509760" y="6565392"/>
-            <a:ext cx="2194560" cy="219456"/>
-          </a:xfrm>
-          <a:prstGeom prst="rect">
-            <a:avLst/>
-          </a:prstGeom>
-          <a:noFill/>
-        </p:spPr>
-        <p:txBody>
-          <a:bodyPr wrap="square" a:anchor="t"/>
-          <a:lstStyle/>
-          <a:p>
-            <a:pPr algn="r"/>
-            <a:r>
-              <a:rPr sz="1000" b="0">
-                <a:solidFill>
-                  <a:srgbClr val="8A8478"/>
-                </a:solidFill>
-                <a:latin typeface="Calibri"/>
-              </a:rPr>
-              <a:t>8 / 12</a:t>
+              <a:t>Internal  ·  v1.1  ·  © G-AsiaPacific</a:t>
             </a:r>
           </a:p>
         </p:txBody>
@@ -9941,7 +8984,7 @@
                 </a:solidFill>
                 <a:latin typeface="Calibri"/>
               </a:rPr>
-              <a:t>8. TWO CLOCKS AND BUTTONS</a:t>
+              <a:t>TWO CLOCKS AND BUTTONS</a:t>
             </a:r>
           </a:p>
         </p:txBody>
@@ -10852,7 +9895,7 @@
         <p:spPr>
           <a:xfrm>
             <a:off x="457200" y="6565392"/>
-            <a:ext cx="8686800" cy="219456"/>
+            <a:ext cx="11247120" cy="219456"/>
           </a:xfrm>
           <a:prstGeom prst="rect">
             <a:avLst/>
@@ -10871,40 +9914,7 @@
                 </a:solidFill>
                 <a:latin typeface="Calibri"/>
               </a:rPr>
-              <a:t>GAP-GUIDE-2026-001  ·  Internal  ·  v1.1</a:t>
-            </a:r>
-          </a:p>
-        </p:txBody>
-      </p:sp>
-      <p:sp>
-        <p:nvSpPr>
-          <p:cNvPr id="30" name="TextBox 29"/>
-          <p:cNvSpPr txBox="1"/>
-          <p:nvPr/>
-        </p:nvSpPr>
-        <p:spPr>
-          <a:xfrm>
-            <a:off x="9509760" y="6565392"/>
-            <a:ext cx="2194560" cy="219456"/>
-          </a:xfrm>
-          <a:prstGeom prst="rect">
-            <a:avLst/>
-          </a:prstGeom>
-          <a:noFill/>
-        </p:spPr>
-        <p:txBody>
-          <a:bodyPr wrap="square" a:anchor="t"/>
-          <a:lstStyle/>
-          <a:p>
-            <a:pPr algn="r"/>
-            <a:r>
-              <a:rPr sz="1000" b="0">
-                <a:solidFill>
-                  <a:srgbClr val="8A8478"/>
-                </a:solidFill>
-                <a:latin typeface="Calibri"/>
-              </a:rPr>
-              <a:t>9 / 12</a:t>
+              <a:t>Internal  ·  v1.1  ·  © G-AsiaPacific</a:t>
             </a:r>
           </a:p>
         </p:txBody>

</xml_diff>